<commit_message>
apresentação qualificação versão final
</commit_message>
<xml_diff>
--- a/ApresentaçãoQualificação.pptx
+++ b/ApresentaçãoQualificação.pptx
@@ -9,14 +9,18 @@
     <p:sldId id="257" r:id="rId3"/>
     <p:sldId id="264" r:id="rId4"/>
     <p:sldId id="263" r:id="rId5"/>
-    <p:sldId id="265" r:id="rId6"/>
-    <p:sldId id="270" r:id="rId7"/>
-    <p:sldId id="272" r:id="rId8"/>
-    <p:sldId id="271" r:id="rId9"/>
-    <p:sldId id="266" r:id="rId10"/>
-    <p:sldId id="267" r:id="rId11"/>
-    <p:sldId id="268" r:id="rId12"/>
-    <p:sldId id="269" r:id="rId13"/>
+    <p:sldId id="273" r:id="rId6"/>
+    <p:sldId id="265" r:id="rId7"/>
+    <p:sldId id="270" r:id="rId8"/>
+    <p:sldId id="272" r:id="rId9"/>
+    <p:sldId id="271" r:id="rId10"/>
+    <p:sldId id="266" r:id="rId11"/>
+    <p:sldId id="275" r:id="rId12"/>
+    <p:sldId id="276" r:id="rId13"/>
+    <p:sldId id="267" r:id="rId14"/>
+    <p:sldId id="277" r:id="rId15"/>
+    <p:sldId id="268" r:id="rId16"/>
+    <p:sldId id="269" r:id="rId17"/>
   </p:sldIdLst>
   <p:sldSz cx="9144000" cy="6858000" type="screen4x3"/>
   <p:notesSz cx="6858000" cy="9144000"/>
@@ -3163,7 +3167,7 @@
           <a:graphicData uri="http://schemas.openxmlformats.org/presentationml/2006/ole">
             <mc:AlternateContent xmlns:mc="http://schemas.openxmlformats.org/markup-compatibility/2006">
               <mc:Choice xmlns:v="urn:schemas-microsoft-com:vml" Requires="v">
-                <p:oleObj spid="_x0000_s1051" name="Imagem de Bitmap" r:id="rId3" imgW="847843" imgH="942857" progId="Paint.Picture">
+                <p:oleObj spid="_x0000_s1063" name="Imagem de Bitmap" r:id="rId3" imgW="847843" imgH="942857" progId="Paint.Picture">
                   <p:embed/>
                 </p:oleObj>
               </mc:Choice>
@@ -3487,7 +3491,7 @@
           <a:p>
             <a:r>
               <a:rPr lang="pt-BR" dirty="0"/>
-              <a:t>Resultados</a:t>
+              <a:t>Metodologia</a:t>
             </a:r>
           </a:p>
         </p:txBody>
@@ -3509,21 +3513,67 @@
           </a:xfrm>
         </p:spPr>
         <p:txBody>
-          <a:bodyPr>
-            <a:normAutofit/>
-          </a:bodyPr>
+          <a:bodyPr/>
           <a:lstStyle/>
           <a:p>
             <a:r>
               <a:rPr lang="pt-BR" b="1" dirty="0"/>
-              <a:t>Domínio do Tempo:</a:t>
+              <a:t>Busca de Samples:</a:t>
             </a:r>
           </a:p>
           <a:p>
             <a:pPr lvl="1"/>
             <a:r>
               <a:rPr lang="pt-BR" b="1" dirty="0"/>
-              <a:t>Ineficiente, pode ser beneficiado pelo desenvolvimentos de algoritmos de extração de envelope</a:t>
+              <a:t>Variedade, Qualidade, Licença, Organização</a:t>
+            </a:r>
+          </a:p>
+          <a:p>
+            <a:r>
+              <a:rPr lang="pt-BR" b="1" dirty="0"/>
+              <a:t>Domínio do tempo:</a:t>
+            </a:r>
+          </a:p>
+          <a:p>
+            <a:pPr lvl="1"/>
+            <a:r>
+              <a:rPr lang="pt-BR" b="1" dirty="0"/>
+              <a:t>Redes Densas – </a:t>
+            </a:r>
+            <a:r>
+              <a:rPr lang="pt-BR" b="1" i="1" dirty="0"/>
+              <a:t>Grid </a:t>
+            </a:r>
+            <a:r>
+              <a:rPr lang="pt-BR" b="1" i="1" dirty="0" err="1"/>
+              <a:t>Search</a:t>
+            </a:r>
+            <a:r>
+              <a:rPr lang="pt-BR" b="1" dirty="0"/>
+              <a:t> (Arquitetura, </a:t>
+            </a:r>
+            <a:r>
+              <a:rPr lang="pt-BR" b="1" dirty="0" err="1"/>
+              <a:t>opt,etc</a:t>
+            </a:r>
+            <a:r>
+              <a:rPr lang="pt-BR" b="1" dirty="0"/>
+              <a:t>)</a:t>
+            </a:r>
+          </a:p>
+          <a:p>
+            <a:pPr lvl="1"/>
+            <a:r>
+              <a:rPr lang="pt-BR" b="1" dirty="0"/>
+              <a:t>Redes Recorrentes + </a:t>
+            </a:r>
+            <a:r>
+              <a:rPr lang="pt-BR" b="1" dirty="0" err="1"/>
+              <a:t>Conv</a:t>
+            </a:r>
+            <a:r>
+              <a:rPr lang="pt-BR" b="1" dirty="0"/>
+              <a:t>. alisada</a:t>
             </a:r>
           </a:p>
           <a:p>
@@ -3536,57 +3586,48 @@
             <a:pPr lvl="1"/>
             <a:r>
               <a:rPr lang="pt-BR" b="1" dirty="0"/>
-              <a:t>Método Direto: Funcional para sons mal comportados(percussão)</a:t>
+              <a:t>Representações</a:t>
             </a:r>
           </a:p>
           <a:p>
             <a:pPr lvl="1"/>
             <a:r>
               <a:rPr lang="pt-BR" b="1" dirty="0"/>
-              <a:t>Método Fisicamente informado:</a:t>
-            </a:r>
-          </a:p>
-          <a:p>
-            <a:pPr lvl="2"/>
+              <a:t>Aplicação direta de redes Densas</a:t>
+            </a:r>
+          </a:p>
+          <a:p>
+            <a:pPr lvl="1"/>
             <a:r>
               <a:rPr lang="pt-BR" b="1" dirty="0"/>
-              <a:t>Ideal para instrumentos harmônicos</a:t>
-            </a:r>
-          </a:p>
-          <a:p>
-            <a:pPr lvl="2"/>
+              <a:t>Aplicação fisicamente informada</a:t>
+            </a:r>
+          </a:p>
+          <a:p>
             <a:r>
               <a:rPr lang="pt-BR" b="1" dirty="0"/>
-              <a:t>Eficiência 10x melhor do que Digital </a:t>
-            </a:r>
-            <a:r>
-              <a:rPr lang="pt-BR" b="1" dirty="0" err="1"/>
-              <a:t>Waveguides</a:t>
-            </a:r>
-            <a:endParaRPr lang="pt-BR" b="1" dirty="0"/>
-          </a:p>
-          <a:p>
-            <a:pPr lvl="2"/>
+              <a:t>Modelos Tradicionais</a:t>
+            </a:r>
+          </a:p>
+          <a:p>
+            <a:pPr lvl="1"/>
             <a:r>
               <a:rPr lang="pt-BR" b="1" dirty="0"/>
-              <a:t>Verossimilhança comparável a diferenças finitas</a:t>
+              <a:t>Implementação e análise</a:t>
             </a:r>
           </a:p>
           <a:p>
             <a:pPr marL="0" indent="0">
               <a:buNone/>
             </a:pPr>
-            <a:r>
-              <a:rPr lang="pt-BR" dirty="0"/>
-              <a:t>	</a:t>
-            </a:r>
+            <a:endParaRPr lang="pt-BR" dirty="0"/>
           </a:p>
         </p:txBody>
       </p:sp>
     </p:spTree>
     <p:extLst>
       <p:ext uri="{BB962C8B-B14F-4D97-AF65-F5344CB8AC3E}">
-        <p14:creationId xmlns:p14="http://schemas.microsoft.com/office/powerpoint/2010/main" val="4236332563"/>
+        <p14:creationId xmlns:p14="http://schemas.microsoft.com/office/powerpoint/2010/main" val="1295817248"/>
       </p:ext>
     </p:extLst>
   </p:cSld>
@@ -3637,6 +3678,564 @@
           <a:p>
             <a:r>
               <a:rPr lang="pt-BR" dirty="0"/>
+              <a:t>Resultados</a:t>
+            </a:r>
+          </a:p>
+        </p:txBody>
+      </p:sp>
+      <p:sp>
+        <p:nvSpPr>
+          <p:cNvPr id="3" name="Espaço Reservado para Conteúdo 2"/>
+          <p:cNvSpPr>
+            <a:spLocks noGrp="1"/>
+          </p:cNvSpPr>
+          <p:nvPr>
+            <p:ph idx="1"/>
+          </p:nvPr>
+        </p:nvSpPr>
+        <p:spPr>
+          <a:xfrm>
+            <a:off x="0" y="692696"/>
+            <a:ext cx="9140514" cy="6165304"/>
+          </a:xfrm>
+        </p:spPr>
+        <p:txBody>
+          <a:bodyPr>
+            <a:normAutofit/>
+          </a:bodyPr>
+          <a:lstStyle/>
+          <a:p>
+            <a:r>
+              <a:rPr lang="pt-BR" b="1" dirty="0"/>
+              <a:t>Domínio do Tempo:</a:t>
+            </a:r>
+          </a:p>
+          <a:p>
+            <a:pPr lvl="1"/>
+            <a:r>
+              <a:rPr lang="pt-BR" b="1" dirty="0"/>
+              <a:t>Ineficiente, pode ser beneficiado pelo desenvolvimentos de algoritmos de extração de </a:t>
+            </a:r>
+            <a:r>
+              <a:rPr lang="pt-BR" b="1" dirty="0" err="1"/>
+              <a:t>envelopetas</a:t>
+            </a:r>
+            <a:endParaRPr lang="pt-BR" b="1" dirty="0"/>
+          </a:p>
+          <a:p>
+            <a:pPr marL="0" indent="0">
+              <a:buNone/>
+            </a:pPr>
+            <a:r>
+              <a:rPr lang="pt-BR" dirty="0"/>
+              <a:t>	</a:t>
+            </a:r>
+          </a:p>
+        </p:txBody>
+      </p:sp>
+      <p:pic>
+        <p:nvPicPr>
+          <p:cNvPr id="5" name="Picture 4">
+            <a:extLst>
+              <a:ext uri="{FF2B5EF4-FFF2-40B4-BE49-F238E27FC236}">
+                <a16:creationId xmlns:a16="http://schemas.microsoft.com/office/drawing/2014/main" id="{F3E4F10B-8CD7-48D8-A1E1-6B2436E384CF}"/>
+              </a:ext>
+            </a:extLst>
+          </p:cNvPr>
+          <p:cNvPicPr>
+            <a:picLocks noChangeAspect="1"/>
+          </p:cNvPicPr>
+          <p:nvPr/>
+        </p:nvPicPr>
+        <p:blipFill>
+          <a:blip r:embed="rId2">
+            <a:extLst>
+              <a:ext uri="{28A0092B-C50C-407E-A947-70E740481C1C}">
+                <a14:useLocalDpi xmlns:a14="http://schemas.microsoft.com/office/drawing/2010/main" val="0"/>
+              </a:ext>
+            </a:extLst>
+          </a:blip>
+          <a:stretch>
+            <a:fillRect/>
+          </a:stretch>
+        </p:blipFill>
+        <p:spPr>
+          <a:xfrm>
+            <a:off x="0" y="2636912"/>
+            <a:ext cx="9144000" cy="4200102"/>
+          </a:xfrm>
+          <a:prstGeom prst="rect">
+            <a:avLst/>
+          </a:prstGeom>
+        </p:spPr>
+      </p:pic>
+    </p:spTree>
+    <p:extLst>
+      <p:ext uri="{BB962C8B-B14F-4D97-AF65-F5344CB8AC3E}">
+        <p14:creationId xmlns:p14="http://schemas.microsoft.com/office/powerpoint/2010/main" val="4087010692"/>
+      </p:ext>
+    </p:extLst>
+  </p:cSld>
+  <p:clrMapOvr>
+    <a:masterClrMapping/>
+  </p:clrMapOvr>
+</p:sld>
+</file>
+
+<file path=ppt/slides/slide12.xml><?xml version="1.0" encoding="utf-8"?>
+<p:sld xmlns:a="http://schemas.openxmlformats.org/drawingml/2006/main" xmlns:r="http://schemas.openxmlformats.org/officeDocument/2006/relationships" xmlns:p="http://schemas.openxmlformats.org/presentationml/2006/main">
+  <p:cSld>
+    <p:spTree>
+      <p:nvGrpSpPr>
+        <p:cNvPr id="1" name=""/>
+        <p:cNvGrpSpPr/>
+        <p:nvPr/>
+      </p:nvGrpSpPr>
+      <p:grpSpPr>
+        <a:xfrm>
+          <a:off x="0" y="0"/>
+          <a:ext cx="0" cy="0"/>
+          <a:chOff x="0" y="0"/>
+          <a:chExt cx="0" cy="0"/>
+        </a:xfrm>
+      </p:grpSpPr>
+      <p:pic>
+        <p:nvPicPr>
+          <p:cNvPr id="6" name="Picture 5">
+            <a:extLst>
+              <a:ext uri="{FF2B5EF4-FFF2-40B4-BE49-F238E27FC236}">
+                <a16:creationId xmlns:a16="http://schemas.microsoft.com/office/drawing/2014/main" id="{E132E19A-5B76-407B-9DAC-2D48894B415C}"/>
+              </a:ext>
+            </a:extLst>
+          </p:cNvPr>
+          <p:cNvPicPr>
+            <a:picLocks noChangeAspect="1"/>
+          </p:cNvPicPr>
+          <p:nvPr/>
+        </p:nvPicPr>
+        <p:blipFill>
+          <a:blip r:embed="rId2">
+            <a:extLst>
+              <a:ext uri="{28A0092B-C50C-407E-A947-70E740481C1C}">
+                <a14:useLocalDpi xmlns:a14="http://schemas.microsoft.com/office/drawing/2010/main" val="0"/>
+              </a:ext>
+            </a:extLst>
+          </a:blip>
+          <a:stretch>
+            <a:fillRect/>
+          </a:stretch>
+        </p:blipFill>
+        <p:spPr>
+          <a:xfrm>
+            <a:off x="19281" y="178308"/>
+            <a:ext cx="9144000" cy="6501384"/>
+          </a:xfrm>
+          <a:prstGeom prst="rect">
+            <a:avLst/>
+          </a:prstGeom>
+        </p:spPr>
+      </p:pic>
+    </p:spTree>
+    <p:extLst>
+      <p:ext uri="{BB962C8B-B14F-4D97-AF65-F5344CB8AC3E}">
+        <p14:creationId xmlns:p14="http://schemas.microsoft.com/office/powerpoint/2010/main" val="4109228628"/>
+      </p:ext>
+    </p:extLst>
+  </p:cSld>
+  <p:clrMapOvr>
+    <a:masterClrMapping/>
+  </p:clrMapOvr>
+</p:sld>
+</file>
+
+<file path=ppt/slides/slide13.xml><?xml version="1.0" encoding="utf-8"?>
+<p:sld xmlns:a="http://schemas.openxmlformats.org/drawingml/2006/main" xmlns:r="http://schemas.openxmlformats.org/officeDocument/2006/relationships" xmlns:p="http://schemas.openxmlformats.org/presentationml/2006/main">
+  <p:cSld>
+    <p:spTree>
+      <p:nvGrpSpPr>
+        <p:cNvPr id="1" name=""/>
+        <p:cNvGrpSpPr/>
+        <p:nvPr/>
+      </p:nvGrpSpPr>
+      <p:grpSpPr>
+        <a:xfrm>
+          <a:off x="0" y="0"/>
+          <a:ext cx="0" cy="0"/>
+          <a:chOff x="0" y="0"/>
+          <a:chExt cx="0" cy="0"/>
+        </a:xfrm>
+      </p:grpSpPr>
+      <p:sp>
+        <p:nvSpPr>
+          <p:cNvPr id="2" name="Título 1"/>
+          <p:cNvSpPr>
+            <a:spLocks noGrp="1"/>
+          </p:cNvSpPr>
+          <p:nvPr>
+            <p:ph type="title"/>
+          </p:nvPr>
+        </p:nvSpPr>
+        <p:spPr>
+          <a:xfrm>
+            <a:off x="3484" y="3070"/>
+            <a:ext cx="9140515" cy="833642"/>
+          </a:xfrm>
+        </p:spPr>
+        <p:txBody>
+          <a:bodyPr>
+            <a:normAutofit/>
+          </a:bodyPr>
+          <a:lstStyle/>
+          <a:p>
+            <a:r>
+              <a:rPr lang="pt-BR" dirty="0"/>
+              <a:t>Resultados</a:t>
+            </a:r>
+          </a:p>
+        </p:txBody>
+      </p:sp>
+      <p:sp>
+        <p:nvSpPr>
+          <p:cNvPr id="3" name="Espaço Reservado para Conteúdo 2"/>
+          <p:cNvSpPr>
+            <a:spLocks noGrp="1"/>
+          </p:cNvSpPr>
+          <p:nvPr>
+            <p:ph idx="1"/>
+          </p:nvPr>
+        </p:nvSpPr>
+        <p:spPr>
+          <a:xfrm>
+            <a:off x="0" y="692696"/>
+            <a:ext cx="9140514" cy="6165304"/>
+          </a:xfrm>
+        </p:spPr>
+        <p:txBody>
+          <a:bodyPr>
+            <a:normAutofit/>
+          </a:bodyPr>
+          <a:lstStyle/>
+          <a:p>
+            <a:r>
+              <a:rPr lang="pt-BR" b="1" dirty="0"/>
+              <a:t>Domínio da Frequência:</a:t>
+            </a:r>
+          </a:p>
+          <a:p>
+            <a:pPr lvl="1"/>
+            <a:r>
+              <a:rPr lang="pt-BR" b="1" dirty="0"/>
+              <a:t>Método Direto: Funcional para sons mal comportados(percussão)</a:t>
+            </a:r>
+          </a:p>
+          <a:p>
+            <a:pPr lvl="1"/>
+            <a:r>
+              <a:rPr lang="pt-BR" b="1" dirty="0"/>
+              <a:t>Método Fisicamente informado:</a:t>
+            </a:r>
+          </a:p>
+          <a:p>
+            <a:pPr lvl="2"/>
+            <a:r>
+              <a:rPr lang="pt-BR" b="1" dirty="0"/>
+              <a:t>Ideal para instrumentos harmônicos</a:t>
+            </a:r>
+          </a:p>
+          <a:p>
+            <a:pPr lvl="2"/>
+            <a:r>
+              <a:rPr lang="pt-BR" b="1" dirty="0"/>
+              <a:t>Eficiência 10x melhor do que Digital </a:t>
+            </a:r>
+            <a:r>
+              <a:rPr lang="pt-BR" b="1" dirty="0" err="1"/>
+              <a:t>Waveguides</a:t>
+            </a:r>
+            <a:endParaRPr lang="pt-BR" b="1" dirty="0"/>
+          </a:p>
+          <a:p>
+            <a:pPr lvl="2"/>
+            <a:r>
+              <a:rPr lang="pt-BR" b="1" dirty="0"/>
+              <a:t>Verossimilhança comparável a diferenças finitas</a:t>
+            </a:r>
+          </a:p>
+          <a:p>
+            <a:pPr marL="0" indent="0">
+              <a:buNone/>
+            </a:pPr>
+            <a:r>
+              <a:rPr lang="pt-BR" dirty="0"/>
+              <a:t>	</a:t>
+            </a:r>
+          </a:p>
+        </p:txBody>
+      </p:sp>
+      <p:pic>
+        <p:nvPicPr>
+          <p:cNvPr id="7" name="Picture 6">
+            <a:extLst>
+              <a:ext uri="{FF2B5EF4-FFF2-40B4-BE49-F238E27FC236}">
+                <a16:creationId xmlns:a16="http://schemas.microsoft.com/office/drawing/2014/main" id="{462ADC37-E9C8-4C91-9918-5E014D9D8B0E}"/>
+              </a:ext>
+            </a:extLst>
+          </p:cNvPr>
+          <p:cNvPicPr>
+            <a:picLocks noChangeAspect="1"/>
+          </p:cNvPicPr>
+          <p:nvPr/>
+        </p:nvPicPr>
+        <p:blipFill>
+          <a:blip r:embed="rId2">
+            <a:extLst>
+              <a:ext uri="{28A0092B-C50C-407E-A947-70E740481C1C}">
+                <a14:useLocalDpi xmlns:a14="http://schemas.microsoft.com/office/drawing/2010/main" val="0"/>
+              </a:ext>
+            </a:extLst>
+          </a:blip>
+          <a:stretch>
+            <a:fillRect/>
+          </a:stretch>
+        </p:blipFill>
+        <p:spPr>
+          <a:xfrm>
+            <a:off x="-5834" y="4510503"/>
+            <a:ext cx="9144000" cy="2360110"/>
+          </a:xfrm>
+          <a:prstGeom prst="rect">
+            <a:avLst/>
+          </a:prstGeom>
+        </p:spPr>
+      </p:pic>
+    </p:spTree>
+    <p:extLst>
+      <p:ext uri="{BB962C8B-B14F-4D97-AF65-F5344CB8AC3E}">
+        <p14:creationId xmlns:p14="http://schemas.microsoft.com/office/powerpoint/2010/main" val="4236332563"/>
+      </p:ext>
+    </p:extLst>
+  </p:cSld>
+  <p:clrMapOvr>
+    <a:masterClrMapping/>
+  </p:clrMapOvr>
+</p:sld>
+</file>
+
+<file path=ppt/slides/slide14.xml><?xml version="1.0" encoding="utf-8"?>
+<p:sld xmlns:a="http://schemas.openxmlformats.org/drawingml/2006/main" xmlns:r="http://schemas.openxmlformats.org/officeDocument/2006/relationships" xmlns:p="http://schemas.openxmlformats.org/presentationml/2006/main">
+  <p:cSld>
+    <p:spTree>
+      <p:nvGrpSpPr>
+        <p:cNvPr id="1" name=""/>
+        <p:cNvGrpSpPr/>
+        <p:nvPr/>
+      </p:nvGrpSpPr>
+      <p:grpSpPr>
+        <a:xfrm>
+          <a:off x="0" y="0"/>
+          <a:ext cx="0" cy="0"/>
+          <a:chOff x="0" y="0"/>
+          <a:chExt cx="0" cy="0"/>
+        </a:xfrm>
+      </p:grpSpPr>
+      <p:pic>
+        <p:nvPicPr>
+          <p:cNvPr id="13" name="Picture 12">
+            <a:extLst>
+              <a:ext uri="{FF2B5EF4-FFF2-40B4-BE49-F238E27FC236}">
+                <a16:creationId xmlns:a16="http://schemas.microsoft.com/office/drawing/2014/main" id="{65EFDEFA-C4E5-418F-B187-ECCACD34C694}"/>
+              </a:ext>
+            </a:extLst>
+          </p:cNvPr>
+          <p:cNvPicPr>
+            <a:picLocks noChangeAspect="1"/>
+          </p:cNvPicPr>
+          <p:nvPr/>
+        </p:nvPicPr>
+        <p:blipFill>
+          <a:blip r:embed="rId2">
+            <a:extLst>
+              <a:ext uri="{28A0092B-C50C-407E-A947-70E740481C1C}">
+                <a14:useLocalDpi xmlns:a14="http://schemas.microsoft.com/office/drawing/2010/main" val="0"/>
+              </a:ext>
+            </a:extLst>
+          </a:blip>
+          <a:stretch>
+            <a:fillRect/>
+          </a:stretch>
+        </p:blipFill>
+        <p:spPr>
+          <a:xfrm>
+            <a:off x="-1286" y="3140968"/>
+            <a:ext cx="9144000" cy="1828800"/>
+          </a:xfrm>
+          <a:prstGeom prst="rect">
+            <a:avLst/>
+          </a:prstGeom>
+        </p:spPr>
+      </p:pic>
+      <p:pic>
+        <p:nvPicPr>
+          <p:cNvPr id="9" name="Picture 8">
+            <a:extLst>
+              <a:ext uri="{FF2B5EF4-FFF2-40B4-BE49-F238E27FC236}">
+                <a16:creationId xmlns:a16="http://schemas.microsoft.com/office/drawing/2014/main" id="{C3B0BF33-FF3C-4425-8832-8817F3320024}"/>
+              </a:ext>
+            </a:extLst>
+          </p:cNvPr>
+          <p:cNvPicPr>
+            <a:picLocks noChangeAspect="1"/>
+          </p:cNvPicPr>
+          <p:nvPr/>
+        </p:nvPicPr>
+        <p:blipFill>
+          <a:blip r:embed="rId3">
+            <a:extLst>
+              <a:ext uri="{28A0092B-C50C-407E-A947-70E740481C1C}">
+                <a14:useLocalDpi xmlns:a14="http://schemas.microsoft.com/office/drawing/2010/main" val="0"/>
+              </a:ext>
+            </a:extLst>
+          </a:blip>
+          <a:stretch>
+            <a:fillRect/>
+          </a:stretch>
+        </p:blipFill>
+        <p:spPr>
+          <a:xfrm>
+            <a:off x="0" y="1528192"/>
+            <a:ext cx="9144000" cy="1828800"/>
+          </a:xfrm>
+          <a:prstGeom prst="rect">
+            <a:avLst/>
+          </a:prstGeom>
+        </p:spPr>
+      </p:pic>
+      <p:pic>
+        <p:nvPicPr>
+          <p:cNvPr id="7" name="Picture 6">
+            <a:extLst>
+              <a:ext uri="{FF2B5EF4-FFF2-40B4-BE49-F238E27FC236}">
+                <a16:creationId xmlns:a16="http://schemas.microsoft.com/office/drawing/2014/main" id="{73970FA2-3AD5-49EB-8433-A9D58558574E}"/>
+              </a:ext>
+            </a:extLst>
+          </p:cNvPr>
+          <p:cNvPicPr>
+            <a:picLocks noChangeAspect="1"/>
+          </p:cNvPicPr>
+          <p:nvPr/>
+        </p:nvPicPr>
+        <p:blipFill>
+          <a:blip r:embed="rId4">
+            <a:extLst>
+              <a:ext uri="{28A0092B-C50C-407E-A947-70E740481C1C}">
+                <a14:useLocalDpi xmlns:a14="http://schemas.microsoft.com/office/drawing/2010/main" val="0"/>
+              </a:ext>
+            </a:extLst>
+          </a:blip>
+          <a:stretch>
+            <a:fillRect/>
+          </a:stretch>
+        </p:blipFill>
+        <p:spPr>
+          <a:xfrm>
+            <a:off x="0" y="-99392"/>
+            <a:ext cx="9144000" cy="1828800"/>
+          </a:xfrm>
+          <a:prstGeom prst="rect">
+            <a:avLst/>
+          </a:prstGeom>
+        </p:spPr>
+      </p:pic>
+      <p:pic>
+        <p:nvPicPr>
+          <p:cNvPr id="11" name="Picture 10">
+            <a:extLst>
+              <a:ext uri="{FF2B5EF4-FFF2-40B4-BE49-F238E27FC236}">
+                <a16:creationId xmlns:a16="http://schemas.microsoft.com/office/drawing/2014/main" id="{0CF056CB-7F18-4568-8C32-D472A515B5AE}"/>
+              </a:ext>
+            </a:extLst>
+          </p:cNvPr>
+          <p:cNvPicPr>
+            <a:picLocks noChangeAspect="1"/>
+          </p:cNvPicPr>
+          <p:nvPr/>
+        </p:nvPicPr>
+        <p:blipFill>
+          <a:blip r:embed="rId5">
+            <a:extLst>
+              <a:ext uri="{28A0092B-C50C-407E-A947-70E740481C1C}">
+                <a14:useLocalDpi xmlns:a14="http://schemas.microsoft.com/office/drawing/2010/main" val="0"/>
+              </a:ext>
+            </a:extLst>
+          </a:blip>
+          <a:stretch>
+            <a:fillRect/>
+          </a:stretch>
+        </p:blipFill>
+        <p:spPr>
+          <a:xfrm>
+            <a:off x="0" y="5017756"/>
+            <a:ext cx="9144000" cy="1828800"/>
+          </a:xfrm>
+          <a:prstGeom prst="rect">
+            <a:avLst/>
+          </a:prstGeom>
+        </p:spPr>
+      </p:pic>
+    </p:spTree>
+    <p:extLst>
+      <p:ext uri="{BB962C8B-B14F-4D97-AF65-F5344CB8AC3E}">
+        <p14:creationId xmlns:p14="http://schemas.microsoft.com/office/powerpoint/2010/main" val="994866762"/>
+      </p:ext>
+    </p:extLst>
+  </p:cSld>
+  <p:clrMapOvr>
+    <a:masterClrMapping/>
+  </p:clrMapOvr>
+</p:sld>
+</file>
+
+<file path=ppt/slides/slide15.xml><?xml version="1.0" encoding="utf-8"?>
+<p:sld xmlns:a="http://schemas.openxmlformats.org/drawingml/2006/main" xmlns:r="http://schemas.openxmlformats.org/officeDocument/2006/relationships" xmlns:p="http://schemas.openxmlformats.org/presentationml/2006/main">
+  <p:cSld>
+    <p:spTree>
+      <p:nvGrpSpPr>
+        <p:cNvPr id="1" name=""/>
+        <p:cNvGrpSpPr/>
+        <p:nvPr/>
+      </p:nvGrpSpPr>
+      <p:grpSpPr>
+        <a:xfrm>
+          <a:off x="0" y="0"/>
+          <a:ext cx="0" cy="0"/>
+          <a:chOff x="0" y="0"/>
+          <a:chExt cx="0" cy="0"/>
+        </a:xfrm>
+      </p:grpSpPr>
+      <p:sp>
+        <p:nvSpPr>
+          <p:cNvPr id="2" name="Título 1"/>
+          <p:cNvSpPr>
+            <a:spLocks noGrp="1"/>
+          </p:cNvSpPr>
+          <p:nvPr>
+            <p:ph type="title"/>
+          </p:nvPr>
+        </p:nvSpPr>
+        <p:spPr>
+          <a:xfrm>
+            <a:off x="3484" y="3070"/>
+            <a:ext cx="9140515" cy="833642"/>
+          </a:xfrm>
+        </p:spPr>
+        <p:txBody>
+          <a:bodyPr>
+            <a:normAutofit/>
+          </a:bodyPr>
+          <a:lstStyle/>
+          <a:p>
+            <a:r>
+              <a:rPr lang="pt-BR" dirty="0"/>
               <a:t>Conclusão</a:t>
             </a:r>
           </a:p>
@@ -3728,7 +4327,7 @@
 </p:sld>
 </file>
 
-<file path=ppt/slides/slide12.xml><?xml version="1.0" encoding="utf-8"?>
+<file path=ppt/slides/slide16.xml><?xml version="1.0" encoding="utf-8"?>
 <p:sld xmlns:a="http://schemas.openxmlformats.org/drawingml/2006/main" xmlns:r="http://schemas.openxmlformats.org/officeDocument/2006/relationships" xmlns:p="http://schemas.openxmlformats.org/presentationml/2006/main">
   <p:cSld>
     <p:spTree>
@@ -3958,7 +4557,9 @@
           </a:xfrm>
         </p:spPr>
         <p:txBody>
-          <a:bodyPr/>
+          <a:bodyPr>
+            <a:normAutofit lnSpcReduction="10000"/>
+          </a:bodyPr>
           <a:lstStyle/>
           <a:p>
             <a:r>
@@ -3974,7 +4575,7 @@
             </a:r>
             <a:r>
               <a:rPr lang="pt-BR" dirty="0"/>
-              <a:t> aplicadas com sucesso várias áreas</a:t>
+              <a:t> aplicadas com sucesso em várias áreas</a:t>
             </a:r>
           </a:p>
           <a:p>
@@ -3992,6 +4593,13 @@
             </a:r>
           </a:p>
           <a:p>
+            <a:pPr lvl="1"/>
+            <a:r>
+              <a:rPr lang="pt-BR" dirty="0"/>
+              <a:t>Indústria de DMI “estagnada”</a:t>
+            </a:r>
+          </a:p>
+          <a:p>
             <a:r>
               <a:rPr lang="pt-BR" b="1" dirty="0"/>
               <a:t>Objetivo: </a:t>
@@ -4002,7 +4610,7 @@
             </a:r>
             <a:r>
               <a:rPr lang="pt-BR" dirty="0" err="1"/>
-              <a:t>ARNs</a:t>
+              <a:t>ANNs</a:t>
             </a:r>
             <a:r>
               <a:rPr lang="pt-BR" dirty="0"/>
@@ -4013,21 +4621,21 @@
             <a:pPr lvl="1"/>
             <a:r>
               <a:rPr lang="pt-BR" dirty="0"/>
-              <a:t>Estado da arte em áreas (direta ou ind.) correlatas</a:t>
+              <a:t>Mapear o estado da arte em áreas (direta ou ind.) correlatas</a:t>
             </a:r>
           </a:p>
           <a:p>
             <a:pPr lvl="1"/>
             <a:r>
               <a:rPr lang="pt-BR" dirty="0"/>
-              <a:t>Estado da arte da modelagem acústica “tradicional”</a:t>
+              <a:t>Mapear o estado da arte da modelagem acústica “tradicional”</a:t>
             </a:r>
           </a:p>
           <a:p>
             <a:pPr lvl="1"/>
             <a:r>
               <a:rPr lang="pt-BR" dirty="0"/>
-              <a:t>Potencial de inclusão de Teoria Acústica na eficiência </a:t>
+              <a:t>Potencial de inclusão de teoria acústica na eficiência </a:t>
             </a:r>
           </a:p>
           <a:p>
@@ -4255,24 +4863,18 @@
             </a:r>
             <a:r>
               <a:rPr lang="pt-BR" dirty="0"/>
-              <a:t> – bons resultados para voz</a:t>
+              <a:t> – bons resultados para voz (Magenta)</a:t>
             </a:r>
           </a:p>
           <a:p>
             <a:pPr lvl="1"/>
             <a:r>
               <a:rPr lang="pt-BR" dirty="0"/>
-              <a:t>Estado da arte em áreas afins</a:t>
+              <a:t>Alguns trabalhos experimentais no princípio</a:t>
             </a:r>
           </a:p>
           <a:p>
             <a:pPr lvl="1"/>
-            <a:r>
-              <a:rPr lang="pt-BR" dirty="0"/>
-              <a:t>Poucos trabalhos relacionados a síntese sonora (nenhum em tempo real)</a:t>
-            </a:r>
-          </a:p>
-          <a:p>
             <a:r>
               <a:rPr lang="pt-BR" b="1" dirty="0"/>
               <a:t>Modelagem Acústica:</a:t>
@@ -4350,7 +4952,7 @@
         </p:blipFill>
         <p:spPr>
           <a:xfrm>
-            <a:off x="4211960" y="4810978"/>
+            <a:off x="179512" y="4797152"/>
             <a:ext cx="3923928" cy="1867789"/>
           </a:xfrm>
           <a:prstGeom prst="rect">
@@ -4388,6 +4990,352 @@
           <a:chExt cx="0" cy="0"/>
         </a:xfrm>
       </p:grpSpPr>
+      <p:pic>
+        <p:nvPicPr>
+          <p:cNvPr id="10" name="DigitalWaveguide">
+            <a:hlinkClick r:id="" action="ppaction://media"/>
+            <a:extLst>
+              <a:ext uri="{FF2B5EF4-FFF2-40B4-BE49-F238E27FC236}">
+                <a16:creationId xmlns:a16="http://schemas.microsoft.com/office/drawing/2014/main" id="{3A104A3C-9617-43E4-A2AD-0CACF759CE18}"/>
+              </a:ext>
+            </a:extLst>
+          </p:cNvPr>
+          <p:cNvPicPr>
+            <a:picLocks noChangeAspect="1"/>
+          </p:cNvPicPr>
+          <p:nvPr>
+            <a:videoFile r:link="rId2"/>
+            <p:extLst>
+              <p:ext uri="{DAA4B4D4-6D71-4841-9C94-3DE7FCFB9230}">
+                <p14:media xmlns:p14="http://schemas.microsoft.com/office/powerpoint/2010/main" r:embed="rId1"/>
+              </p:ext>
+            </p:extLst>
+          </p:nvPr>
+        </p:nvPicPr>
+        <p:blipFill>
+          <a:blip r:embed="rId6"/>
+          <a:stretch>
+            <a:fillRect/>
+          </a:stretch>
+        </p:blipFill>
+        <p:spPr>
+          <a:xfrm>
+            <a:off x="447674" y="3346886"/>
+            <a:ext cx="8248649" cy="3511115"/>
+          </a:xfrm>
+          <a:prstGeom prst="rect">
+            <a:avLst/>
+          </a:prstGeom>
+        </p:spPr>
+      </p:pic>
+      <p:pic>
+        <p:nvPicPr>
+          <p:cNvPr id="11" name="FiniteDifference">
+            <a:hlinkClick r:id="" action="ppaction://media"/>
+            <a:extLst>
+              <a:ext uri="{FF2B5EF4-FFF2-40B4-BE49-F238E27FC236}">
+                <a16:creationId xmlns:a16="http://schemas.microsoft.com/office/drawing/2014/main" id="{EBD8D69A-5E37-4294-8D6E-C2D9BC5C741D}"/>
+              </a:ext>
+            </a:extLst>
+          </p:cNvPr>
+          <p:cNvPicPr>
+            <a:picLocks noChangeAspect="1"/>
+          </p:cNvPicPr>
+          <p:nvPr>
+            <a:videoFile r:link="rId4"/>
+            <p:extLst>
+              <p:ext uri="{DAA4B4D4-6D71-4841-9C94-3DE7FCFB9230}">
+                <p14:media xmlns:p14="http://schemas.microsoft.com/office/powerpoint/2010/main" r:embed="rId3"/>
+              </p:ext>
+            </p:extLst>
+          </p:nvPr>
+        </p:nvPicPr>
+        <p:blipFill>
+          <a:blip r:embed="rId7"/>
+          <a:stretch>
+            <a:fillRect/>
+          </a:stretch>
+        </p:blipFill>
+        <p:spPr>
+          <a:xfrm>
+            <a:off x="447675" y="47625"/>
+            <a:ext cx="8248650" cy="3381375"/>
+          </a:xfrm>
+          <a:prstGeom prst="rect">
+            <a:avLst/>
+          </a:prstGeom>
+        </p:spPr>
+      </p:pic>
+    </p:spTree>
+    <p:extLst>
+      <p:ext uri="{BB962C8B-B14F-4D97-AF65-F5344CB8AC3E}">
+        <p14:creationId xmlns:p14="http://schemas.microsoft.com/office/powerpoint/2010/main" val="1060582443"/>
+      </p:ext>
+    </p:extLst>
+  </p:cSld>
+  <p:clrMapOvr>
+    <a:masterClrMapping/>
+  </p:clrMapOvr>
+  <p:timing>
+    <p:tnLst>
+      <p:par>
+        <p:cTn id="1" dur="indefinite" restart="never" nodeType="tmRoot">
+          <p:childTnLst>
+            <p:seq concurrent="1" nextAc="seek">
+              <p:cTn id="2" dur="indefinite" nodeType="mainSeq">
+                <p:childTnLst>
+                  <p:par>
+                    <p:cTn id="3" fill="hold">
+                      <p:stCondLst>
+                        <p:cond delay="indefinite"/>
+                      </p:stCondLst>
+                      <p:childTnLst>
+                        <p:par>
+                          <p:cTn id="4" fill="hold">
+                            <p:stCondLst>
+                              <p:cond delay="0"/>
+                            </p:stCondLst>
+                            <p:childTnLst>
+                              <p:par>
+                                <p:cTn id="5" presetID="1" presetClass="mediacall" presetSubtype="0" fill="hold" nodeType="clickEffect">
+                                  <p:stCondLst>
+                                    <p:cond delay="0"/>
+                                  </p:stCondLst>
+                                  <p:childTnLst>
+                                    <p:cmd type="call" cmd="playFrom(0.0)">
+                                      <p:cBhvr>
+                                        <p:cTn id="6" dur="41709" fill="hold"/>
+                                        <p:tgtEl>
+                                          <p:spTgt spid="10"/>
+                                        </p:tgtEl>
+                                      </p:cBhvr>
+                                    </p:cmd>
+                                  </p:childTnLst>
+                                </p:cTn>
+                              </p:par>
+                            </p:childTnLst>
+                          </p:cTn>
+                        </p:par>
+                      </p:childTnLst>
+                    </p:cTn>
+                  </p:par>
+                  <p:par>
+                    <p:cTn id="7" fill="hold">
+                      <p:stCondLst>
+                        <p:cond delay="indefinite"/>
+                      </p:stCondLst>
+                      <p:childTnLst>
+                        <p:par>
+                          <p:cTn id="8" fill="hold">
+                            <p:stCondLst>
+                              <p:cond delay="0"/>
+                            </p:stCondLst>
+                            <p:childTnLst>
+                              <p:par>
+                                <p:cTn id="9" presetID="1" presetClass="mediacall" presetSubtype="0" fill="hold" nodeType="clickEffect">
+                                  <p:stCondLst>
+                                    <p:cond delay="0"/>
+                                  </p:stCondLst>
+                                  <p:childTnLst>
+                                    <p:cmd type="call" cmd="playFrom(0.0)">
+                                      <p:cBhvr>
+                                        <p:cTn id="10" dur="41709" fill="hold"/>
+                                        <p:tgtEl>
+                                          <p:spTgt spid="11"/>
+                                        </p:tgtEl>
+                                      </p:cBhvr>
+                                    </p:cmd>
+                                  </p:childTnLst>
+                                </p:cTn>
+                              </p:par>
+                            </p:childTnLst>
+                          </p:cTn>
+                        </p:par>
+                      </p:childTnLst>
+                    </p:cTn>
+                  </p:par>
+                </p:childTnLst>
+              </p:cTn>
+              <p:prevCondLst>
+                <p:cond evt="onPrev" delay="0">
+                  <p:tgtEl>
+                    <p:sldTgt/>
+                  </p:tgtEl>
+                </p:cond>
+              </p:prevCondLst>
+              <p:nextCondLst>
+                <p:cond evt="onNext" delay="0">
+                  <p:tgtEl>
+                    <p:sldTgt/>
+                  </p:tgtEl>
+                </p:cond>
+              </p:nextCondLst>
+            </p:seq>
+            <p:video>
+              <p:cMediaNode vol="80000">
+                <p:cTn id="11" fill="hold" display="0">
+                  <p:stCondLst>
+                    <p:cond delay="indefinite"/>
+                  </p:stCondLst>
+                </p:cTn>
+                <p:tgtEl>
+                  <p:spTgt spid="10"/>
+                </p:tgtEl>
+              </p:cMediaNode>
+            </p:video>
+            <p:seq concurrent="1" nextAc="seek">
+              <p:cTn id="12" restart="whenNotActive" fill="hold" evtFilter="cancelBubble" nodeType="interactiveSeq">
+                <p:stCondLst>
+                  <p:cond evt="onClick" delay="0">
+                    <p:tgtEl>
+                      <p:spTgt spid="10"/>
+                    </p:tgtEl>
+                  </p:cond>
+                </p:stCondLst>
+                <p:endSync evt="end" delay="0">
+                  <p:rtn val="all"/>
+                </p:endSync>
+                <p:childTnLst>
+                  <p:par>
+                    <p:cTn id="13" fill="hold">
+                      <p:stCondLst>
+                        <p:cond delay="0"/>
+                      </p:stCondLst>
+                      <p:childTnLst>
+                        <p:par>
+                          <p:cTn id="14" fill="hold">
+                            <p:stCondLst>
+                              <p:cond delay="0"/>
+                            </p:stCondLst>
+                            <p:childTnLst>
+                              <p:par>
+                                <p:cTn id="15" presetID="2" presetClass="mediacall" presetSubtype="0" fill="hold" nodeType="clickEffect">
+                                  <p:stCondLst>
+                                    <p:cond delay="0"/>
+                                  </p:stCondLst>
+                                  <p:childTnLst>
+                                    <p:cmd type="call" cmd="togglePause">
+                                      <p:cBhvr>
+                                        <p:cTn id="16" dur="1" fill="hold"/>
+                                        <p:tgtEl>
+                                          <p:spTgt spid="10"/>
+                                        </p:tgtEl>
+                                      </p:cBhvr>
+                                    </p:cmd>
+                                  </p:childTnLst>
+                                </p:cTn>
+                              </p:par>
+                            </p:childTnLst>
+                          </p:cTn>
+                        </p:par>
+                      </p:childTnLst>
+                    </p:cTn>
+                  </p:par>
+                </p:childTnLst>
+              </p:cTn>
+              <p:nextCondLst>
+                <p:cond evt="onClick" delay="0">
+                  <p:tgtEl>
+                    <p:spTgt spid="10"/>
+                  </p:tgtEl>
+                </p:cond>
+              </p:nextCondLst>
+            </p:seq>
+            <p:video>
+              <p:cMediaNode vol="80000">
+                <p:cTn id="17" fill="hold" display="0">
+                  <p:stCondLst>
+                    <p:cond delay="indefinite"/>
+                  </p:stCondLst>
+                </p:cTn>
+                <p:tgtEl>
+                  <p:spTgt spid="11"/>
+                </p:tgtEl>
+              </p:cMediaNode>
+            </p:video>
+            <p:seq concurrent="1" nextAc="seek">
+              <p:cTn id="18" restart="whenNotActive" fill="hold" evtFilter="cancelBubble" nodeType="interactiveSeq">
+                <p:stCondLst>
+                  <p:cond evt="onClick" delay="0">
+                    <p:tgtEl>
+                      <p:spTgt spid="11"/>
+                    </p:tgtEl>
+                  </p:cond>
+                </p:stCondLst>
+                <p:endSync evt="end" delay="0">
+                  <p:rtn val="all"/>
+                </p:endSync>
+                <p:childTnLst>
+                  <p:par>
+                    <p:cTn id="19" fill="hold">
+                      <p:stCondLst>
+                        <p:cond delay="0"/>
+                      </p:stCondLst>
+                      <p:childTnLst>
+                        <p:par>
+                          <p:cTn id="20" fill="hold">
+                            <p:stCondLst>
+                              <p:cond delay="0"/>
+                            </p:stCondLst>
+                            <p:childTnLst>
+                              <p:par>
+                                <p:cTn id="21" presetID="2" presetClass="mediacall" presetSubtype="0" fill="hold" nodeType="clickEffect">
+                                  <p:stCondLst>
+                                    <p:cond delay="0"/>
+                                  </p:stCondLst>
+                                  <p:childTnLst>
+                                    <p:cmd type="call" cmd="togglePause">
+                                      <p:cBhvr>
+                                        <p:cTn id="22" dur="1" fill="hold"/>
+                                        <p:tgtEl>
+                                          <p:spTgt spid="11"/>
+                                        </p:tgtEl>
+                                      </p:cBhvr>
+                                    </p:cmd>
+                                  </p:childTnLst>
+                                </p:cTn>
+                              </p:par>
+                            </p:childTnLst>
+                          </p:cTn>
+                        </p:par>
+                      </p:childTnLst>
+                    </p:cTn>
+                  </p:par>
+                </p:childTnLst>
+              </p:cTn>
+              <p:nextCondLst>
+                <p:cond evt="onClick" delay="0">
+                  <p:tgtEl>
+                    <p:spTgt spid="11"/>
+                  </p:tgtEl>
+                </p:cond>
+              </p:nextCondLst>
+            </p:seq>
+          </p:childTnLst>
+        </p:cTn>
+      </p:par>
+    </p:tnLst>
+  </p:timing>
+</p:sld>
+</file>
+
+<file path=ppt/slides/slide6.xml><?xml version="1.0" encoding="utf-8"?>
+<p:sld xmlns:a="http://schemas.openxmlformats.org/drawingml/2006/main" xmlns:r="http://schemas.openxmlformats.org/officeDocument/2006/relationships" xmlns:p="http://schemas.openxmlformats.org/presentationml/2006/main">
+  <p:cSld>
+    <p:spTree>
+      <p:nvGrpSpPr>
+        <p:cNvPr id="1" name=""/>
+        <p:cNvGrpSpPr/>
+        <p:nvPr/>
+      </p:nvGrpSpPr>
+      <p:grpSpPr>
+        <a:xfrm>
+          <a:off x="0" y="0"/>
+          <a:ext cx="0" cy="0"/>
+          <a:chOff x="0" y="0"/>
+          <a:chExt cx="0" cy="0"/>
+        </a:xfrm>
+      </p:grpSpPr>
       <p:sp>
         <p:nvSpPr>
           <p:cNvPr id="2" name="Título 1"/>
@@ -4494,7 +5442,7 @@
 </p:sld>
 </file>
 
-<file path=ppt/slides/slide6.xml><?xml version="1.0" encoding="utf-8"?>
+<file path=ppt/slides/slide7.xml><?xml version="1.0" encoding="utf-8"?>
 <p:sld xmlns:a="http://schemas.openxmlformats.org/drawingml/2006/main" xmlns:r="http://schemas.openxmlformats.org/officeDocument/2006/relationships" xmlns:p="http://schemas.openxmlformats.org/presentationml/2006/main">
   <p:cSld>
     <p:spTree>
@@ -4588,18 +5536,68 @@
         </p:nvSpPr>
         <p:spPr>
           <a:xfrm>
-            <a:off x="0" y="692696"/>
-            <a:ext cx="9140514" cy="6165304"/>
-          </a:xfrm>
-        </p:spPr>
-        <p:txBody>
-          <a:bodyPr/>
+            <a:off x="0" y="692695"/>
+            <a:ext cx="9140514" cy="689627"/>
+          </a:xfrm>
+        </p:spPr>
+        <p:txBody>
+          <a:bodyPr>
+            <a:normAutofit fontScale="85000" lnSpcReduction="10000"/>
+          </a:bodyPr>
           <a:lstStyle/>
           <a:p>
             <a:r>
               <a:rPr lang="pt-BR" b="1" dirty="0"/>
-              <a:t>Transformada Discreta de Fourier:</a:t>
-            </a:r>
+              <a:t>Transformada Discreta de Fourier: (</a:t>
+            </a:r>
+            <a:r>
+              <a:rPr lang="pt-BR" dirty="0">
+                <a:hlinkClick r:id="rId3"/>
+              </a:rPr>
+              <a:t> </a:t>
+            </a:r>
+            <a:r>
+              <a:rPr lang="pt-BR" dirty="0" err="1">
+                <a:hlinkClick r:id="rId3"/>
+              </a:rPr>
+              <a:t>Wikimedia</a:t>
+            </a:r>
+            <a:r>
+              <a:rPr lang="pt-BR" dirty="0">
+                <a:hlinkClick r:id="rId3"/>
+              </a:rPr>
+              <a:t> Commons</a:t>
+            </a:r>
+            <a:r>
+              <a:rPr lang="pt-BR" dirty="0"/>
+              <a:t> )</a:t>
+            </a:r>
+          </a:p>
+          <a:p>
+            <a:endParaRPr lang="pt-BR" dirty="0"/>
+          </a:p>
+          <a:p>
+            <a:endParaRPr lang="pt-BR" dirty="0"/>
+          </a:p>
+          <a:p>
+            <a:endParaRPr lang="pt-BR" dirty="0"/>
+          </a:p>
+          <a:p>
+            <a:endParaRPr lang="pt-BR" dirty="0"/>
+          </a:p>
+          <a:p>
+            <a:endParaRPr lang="pt-BR" dirty="0"/>
+          </a:p>
+          <a:p>
+            <a:endParaRPr lang="pt-BR" dirty="0"/>
+          </a:p>
+          <a:p>
+            <a:endParaRPr lang="pt-BR" dirty="0"/>
+          </a:p>
+          <a:p>
+            <a:endParaRPr lang="pt-BR" dirty="0"/>
+          </a:p>
+          <a:p>
             <a:endParaRPr lang="pt-BR" dirty="0"/>
           </a:p>
         </p:txBody>
@@ -4617,7 +5615,7 @@
 </p:sld>
 </file>
 
-<file path=ppt/slides/slide7.xml><?xml version="1.0" encoding="utf-8"?>
+<file path=ppt/slides/slide8.xml><?xml version="1.0" encoding="utf-8"?>
 <p:sld xmlns:a="http://schemas.openxmlformats.org/drawingml/2006/main" xmlns:r="http://schemas.openxmlformats.org/officeDocument/2006/relationships" xmlns:p="http://schemas.openxmlformats.org/presentationml/2006/main">
   <p:cSld>
     <p:spTree>
@@ -4720,7 +5718,7 @@
         <p:spPr>
           <a:xfrm>
             <a:off x="3484" y="1124744"/>
-            <a:ext cx="9144000" cy="3538728"/>
+            <a:ext cx="9144000" cy="5730186"/>
           </a:xfrm>
           <a:prstGeom prst="rect">
             <a:avLst/>
@@ -4740,7 +5738,7 @@
 </p:sld>
 </file>
 
-<file path=ppt/slides/slide8.xml><?xml version="1.0" encoding="utf-8"?>
+<file path=ppt/slides/slide9.xml><?xml version="1.0" encoding="utf-8"?>
 <p:sld xmlns:a="http://schemas.openxmlformats.org/drawingml/2006/main" xmlns:r="http://schemas.openxmlformats.org/officeDocument/2006/relationships" xmlns:p="http://schemas.openxmlformats.org/presentationml/2006/main">
   <p:cSld>
     <p:spTree>
@@ -4857,193 +5855,6 @@
     <p:extLst>
       <p:ext uri="{BB962C8B-B14F-4D97-AF65-F5344CB8AC3E}">
         <p14:creationId xmlns:p14="http://schemas.microsoft.com/office/powerpoint/2010/main" val="1701381379"/>
-      </p:ext>
-    </p:extLst>
-  </p:cSld>
-  <p:clrMapOvr>
-    <a:masterClrMapping/>
-  </p:clrMapOvr>
-</p:sld>
-</file>
-
-<file path=ppt/slides/slide9.xml><?xml version="1.0" encoding="utf-8"?>
-<p:sld xmlns:a="http://schemas.openxmlformats.org/drawingml/2006/main" xmlns:r="http://schemas.openxmlformats.org/officeDocument/2006/relationships" xmlns:p="http://schemas.openxmlformats.org/presentationml/2006/main">
-  <p:cSld>
-    <p:spTree>
-      <p:nvGrpSpPr>
-        <p:cNvPr id="1" name=""/>
-        <p:cNvGrpSpPr/>
-        <p:nvPr/>
-      </p:nvGrpSpPr>
-      <p:grpSpPr>
-        <a:xfrm>
-          <a:off x="0" y="0"/>
-          <a:ext cx="0" cy="0"/>
-          <a:chOff x="0" y="0"/>
-          <a:chExt cx="0" cy="0"/>
-        </a:xfrm>
-      </p:grpSpPr>
-      <p:sp>
-        <p:nvSpPr>
-          <p:cNvPr id="2" name="Título 1"/>
-          <p:cNvSpPr>
-            <a:spLocks noGrp="1"/>
-          </p:cNvSpPr>
-          <p:nvPr>
-            <p:ph type="title"/>
-          </p:nvPr>
-        </p:nvSpPr>
-        <p:spPr>
-          <a:xfrm>
-            <a:off x="3484" y="3070"/>
-            <a:ext cx="9140515" cy="833642"/>
-          </a:xfrm>
-        </p:spPr>
-        <p:txBody>
-          <a:bodyPr>
-            <a:normAutofit/>
-          </a:bodyPr>
-          <a:lstStyle/>
-          <a:p>
-            <a:r>
-              <a:rPr lang="pt-BR" dirty="0"/>
-              <a:t>Metodologia</a:t>
-            </a:r>
-          </a:p>
-        </p:txBody>
-      </p:sp>
-      <p:sp>
-        <p:nvSpPr>
-          <p:cNvPr id="3" name="Espaço Reservado para Conteúdo 2"/>
-          <p:cNvSpPr>
-            <a:spLocks noGrp="1"/>
-          </p:cNvSpPr>
-          <p:nvPr>
-            <p:ph idx="1"/>
-          </p:nvPr>
-        </p:nvSpPr>
-        <p:spPr>
-          <a:xfrm>
-            <a:off x="0" y="692696"/>
-            <a:ext cx="9140514" cy="6165304"/>
-          </a:xfrm>
-        </p:spPr>
-        <p:txBody>
-          <a:bodyPr/>
-          <a:lstStyle/>
-          <a:p>
-            <a:r>
-              <a:rPr lang="pt-BR" b="1" dirty="0"/>
-              <a:t>Busca de Samples:</a:t>
-            </a:r>
-          </a:p>
-          <a:p>
-            <a:pPr lvl="1"/>
-            <a:r>
-              <a:rPr lang="pt-BR" b="1" dirty="0"/>
-              <a:t>Variedade, Qualidade, Licença, Organização</a:t>
-            </a:r>
-          </a:p>
-          <a:p>
-            <a:r>
-              <a:rPr lang="pt-BR" b="1" dirty="0"/>
-              <a:t>Domínio do tempo:</a:t>
-            </a:r>
-          </a:p>
-          <a:p>
-            <a:pPr lvl="1"/>
-            <a:r>
-              <a:rPr lang="pt-BR" b="1" dirty="0"/>
-              <a:t>Redes Densas – </a:t>
-            </a:r>
-            <a:r>
-              <a:rPr lang="pt-BR" b="1" i="1" dirty="0"/>
-              <a:t>Grid </a:t>
-            </a:r>
-            <a:r>
-              <a:rPr lang="pt-BR" b="1" i="1" dirty="0" err="1"/>
-              <a:t>Search</a:t>
-            </a:r>
-            <a:r>
-              <a:rPr lang="pt-BR" b="1" dirty="0"/>
-              <a:t> (Arquitetura, </a:t>
-            </a:r>
-            <a:r>
-              <a:rPr lang="pt-BR" b="1" dirty="0" err="1"/>
-              <a:t>opt,etc</a:t>
-            </a:r>
-            <a:r>
-              <a:rPr lang="pt-BR" b="1" dirty="0"/>
-              <a:t>)</a:t>
-            </a:r>
-          </a:p>
-          <a:p>
-            <a:pPr lvl="1"/>
-            <a:r>
-              <a:rPr lang="pt-BR" b="1" dirty="0"/>
-              <a:t>Redes Recorrentes + </a:t>
-            </a:r>
-            <a:r>
-              <a:rPr lang="pt-BR" b="1" dirty="0" err="1"/>
-              <a:t>Conv</a:t>
-            </a:r>
-            <a:r>
-              <a:rPr lang="pt-BR" b="1" dirty="0"/>
-              <a:t>. alisada</a:t>
-            </a:r>
-          </a:p>
-          <a:p>
-            <a:r>
-              <a:rPr lang="pt-BR" b="1" dirty="0"/>
-              <a:t>Domínio da Frequência:</a:t>
-            </a:r>
-          </a:p>
-          <a:p>
-            <a:pPr lvl="1"/>
-            <a:r>
-              <a:rPr lang="pt-BR" b="1" dirty="0"/>
-              <a:t>Representações</a:t>
-            </a:r>
-          </a:p>
-          <a:p>
-            <a:pPr lvl="1"/>
-            <a:r>
-              <a:rPr lang="pt-BR" b="1" dirty="0"/>
-              <a:t>Aplicação direta de redes Densas</a:t>
-            </a:r>
-          </a:p>
-          <a:p>
-            <a:pPr lvl="1"/>
-            <a:r>
-              <a:rPr lang="pt-BR" b="1" dirty="0"/>
-              <a:t>Aplicação fisicamente informada</a:t>
-            </a:r>
-          </a:p>
-          <a:p>
-            <a:r>
-              <a:rPr lang="pt-BR" b="1" dirty="0"/>
-              <a:t>Modelos Tradicionais</a:t>
-            </a:r>
-          </a:p>
-          <a:p>
-            <a:pPr lvl="1"/>
-            <a:r>
-              <a:rPr lang="pt-BR" b="1" dirty="0"/>
-              <a:t>Implementação e análise</a:t>
-            </a:r>
-          </a:p>
-          <a:p>
-            <a:pPr marL="0" indent="0">
-              <a:buNone/>
-            </a:pPr>
-            <a:endParaRPr lang="pt-BR" dirty="0"/>
-          </a:p>
-        </p:txBody>
-      </p:sp>
-    </p:spTree>
-    <p:extLst>
-      <p:ext uri="{BB962C8B-B14F-4D97-AF65-F5344CB8AC3E}">
-        <p14:creationId xmlns:p14="http://schemas.microsoft.com/office/powerpoint/2010/main" val="1295817248"/>
       </p:ext>
     </p:extLst>
   </p:cSld>

</xml_diff>